<commit_message>
one last change... too late?
</commit_message>
<xml_diff>
--- a/presentation/The main lesson.pptx
+++ b/presentation/The main lesson.pptx
@@ -129,7 +129,7 @@
   <pc:docChgLst>
     <pc:chgData name="Jemma Little" userId="6e23c02541cfb0bd" providerId="LiveId" clId="{B71C111D-398C-466F-BDD7-B627A9C0CF12}"/>
     <pc:docChg chg="undo custSel delSld modSld">
-      <pc:chgData name="Jemma Little" userId="6e23c02541cfb0bd" providerId="LiveId" clId="{B71C111D-398C-466F-BDD7-B627A9C0CF12}" dt="2026-08-03T03:18:25.720" v="4113" actId="20577"/>
+      <pc:chgData name="Jemma Little" userId="6e23c02541cfb0bd" providerId="LiveId" clId="{B71C111D-398C-466F-BDD7-B627A9C0CF12}" dt="2026-08-03T03:47:20.469" v="4172" actId="20577"/>
       <pc:docMkLst>
         <pc:docMk/>
       </pc:docMkLst>
@@ -210,7 +210,7 @@
         </pc:spChg>
       </pc:sldChg>
       <pc:sldChg chg="modSp mod">
-        <pc:chgData name="Jemma Little" userId="6e23c02541cfb0bd" providerId="LiveId" clId="{B71C111D-398C-466F-BDD7-B627A9C0CF12}" dt="2026-08-03T03:18:25.720" v="4113" actId="20577"/>
+        <pc:chgData name="Jemma Little" userId="6e23c02541cfb0bd" providerId="LiveId" clId="{B71C111D-398C-466F-BDD7-B627A9C0CF12}" dt="2026-08-03T03:47:20.469" v="4172" actId="20577"/>
         <pc:sldMkLst>
           <pc:docMk/>
           <pc:sldMk cId="512381374" sldId="261"/>
@@ -224,7 +224,7 @@
           </ac:spMkLst>
         </pc:spChg>
         <pc:spChg chg="mod">
-          <ac:chgData name="Jemma Little" userId="6e23c02541cfb0bd" providerId="LiveId" clId="{B71C111D-398C-466F-BDD7-B627A9C0CF12}" dt="2026-08-03T03:18:25.720" v="4113" actId="20577"/>
+          <ac:chgData name="Jemma Little" userId="6e23c02541cfb0bd" providerId="LiveId" clId="{B71C111D-398C-466F-BDD7-B627A9C0CF12}" dt="2026-08-03T03:47:20.469" v="4172" actId="20577"/>
           <ac:spMkLst>
             <pc:docMk/>
             <pc:sldMk cId="512381374" sldId="261"/>
@@ -4148,7 +4148,7 @@
         </p:spPr>
         <p:txBody>
           <a:bodyPr>
-            <a:normAutofit fontScale="70000" lnSpcReduction="20000"/>
+            <a:normAutofit fontScale="55000" lnSpcReduction="20000"/>
           </a:bodyPr>
           <a:lstStyle/>
           <a:p>
@@ -4182,9 +4182,10 @@
               <a:buNone/>
             </a:pPr>
             <a:r>
-              <a:rPr lang="en-US" dirty="0"/>
-              <a:t>--------------------------------------------------------------------------------------------</a:t>
-            </a:r>
+              <a:rPr lang="en-US"/>
+              <a:t>--------------------------------------------------------------------------------------------------------------------------</a:t>
+            </a:r>
+            <a:endParaRPr lang="en-US" dirty="0"/>
           </a:p>
           <a:p>
             <a:pPr marL="0" indent="0">
@@ -4201,7 +4202,7 @@
             </a:pPr>
             <a:r>
               <a:rPr lang="en-US" dirty="0"/>
-              <a:t>Fruit					Wall					Snake Segment</a:t>
+              <a:t>Fruit					Wall				Snake Segment</a:t>
             </a:r>
             <a:br>
               <a:rPr lang="en-US" dirty="0"/>
@@ -4213,13 +4214,28 @@
             <a:br>
               <a:rPr lang="en-US" dirty="0"/>
             </a:br>
+            <a:r>
+              <a:rPr lang="en-US" dirty="0"/>
+              <a:t>										Snake</a:t>
+            </a:r>
+          </a:p>
+          <a:p>
+            <a:pPr marL="0" indent="0">
+              <a:buNone/>
+            </a:pPr>
+            <a:endParaRPr lang="en-US" dirty="0"/>
+          </a:p>
+          <a:p>
+            <a:pPr marL="0" indent="0">
+              <a:buNone/>
+            </a:pPr>
             <a:r>
               <a:rPr lang="en-US" dirty="0" err="1"/>
               <a:t>GameObject</a:t>
             </a:r>
             <a:r>
               <a:rPr lang="en-US" dirty="0"/>
-              <a:t> :								Snake</a:t>
+              <a:t> :								</a:t>
             </a:r>
             <a:br>
               <a:rPr lang="en-US" dirty="0"/>
@@ -4282,11 +4298,7 @@
             </a:pPr>
             <a:r>
               <a:rPr lang="en-US" dirty="0"/>
-              <a:t>Snake uses composition to manage </a:t>
-            </a:r>
-            <a:r>
-              <a:rPr lang="en-US"/>
-              <a:t>a collection of </a:t>
+              <a:t>Snake uses composition to manage a collection of </a:t>
             </a:r>
             <a:r>
               <a:rPr lang="en-US" dirty="0" err="1"/>

</xml_diff>